<commit_message>
docs: regenerate THELEMA-Presentation.pptx with Arc microgrant text
</commit_message>
<xml_diff>
--- a/THELEMA-Presentation.pptx
+++ b/THELEMA-Presentation.pptx
@@ -3212,7 +3212,7 @@
               </a:defRPr>
             </a:pPr>
             <a:r>
-              <a:t>ETHONLINE 2026 SUBMISSION</a:t>
+              <a:t>ARC MICROGRANT SUBMISSION</a:t>
             </a:r>
           </a:p>
           <a:p>
@@ -4987,7 +4987,7 @@
               </a:defRPr>
             </a:pPr>
             <a:r>
-              <a:t>• Honest Hackathon Reporting: Production contract standby pending organization deploy access.</a:t>
+              <a:t>• Honest Grant Reporting: Production contract standby pending organization deploy access.</a:t>
             </a:r>
           </a:p>
         </p:txBody>

</xml_diff>